<commit_message>
Update screenshots and remove local zip/html report from remote repo
</commit_message>
<xml_diff>
--- a/CashFlow_Chain_Pitch_Deck.pptx
+++ b/CashFlow_Chain_Pitch_Deck.pptx
@@ -4974,7 +4974,7 @@
         <p:spPr>
           <a:xfrm>
             <a:off x="731520" y="1920240"/>
-            <a:ext cx="7498079" cy="3756850"/>
+            <a:ext cx="7498079" cy="4304222"/>
           </a:xfrm>
           <a:prstGeom prst="rect">
             <a:avLst/>
@@ -5259,7 +5259,7 @@
         <p:spPr>
           <a:xfrm>
             <a:off x="731520" y="1920240"/>
-            <a:ext cx="7772400" cy="3894296"/>
+            <a:ext cx="7772400" cy="4461694"/>
           </a:xfrm>
           <a:prstGeom prst="rect">
             <a:avLst/>
@@ -5594,7 +5594,7 @@
         <p:spPr>
           <a:xfrm>
             <a:off x="731520" y="1920240"/>
-            <a:ext cx="7315200" cy="3665220"/>
+            <a:ext cx="7315200" cy="4199241"/>
           </a:xfrm>
           <a:prstGeom prst="rect">
             <a:avLst/>
@@ -6272,7 +6272,7 @@
         <p:spPr>
           <a:xfrm>
             <a:off x="731520" y="1920240"/>
-            <a:ext cx="7498079" cy="3756850"/>
+            <a:ext cx="7498079" cy="4304222"/>
           </a:xfrm>
           <a:prstGeom prst="rect">
             <a:avLst/>
@@ -6553,7 +6553,7 @@
         <p:spPr>
           <a:xfrm>
             <a:off x="731520" y="1920240"/>
-            <a:ext cx="6583680" cy="3298698"/>
+            <a:ext cx="6583680" cy="3779317"/>
           </a:xfrm>
           <a:prstGeom prst="rect">
             <a:avLst/>

</xml_diff>